<commit_message>
Add new PowerPoint presentations and a temporary test file
- Added NNSA PowerPoint Template 2025.pptx
- Added Statistical Analysis LAMBDA Catalog CECOP.pptx
- Added Statistical Analysis Lambda Toolbox Brownbag.pptx
- Added temporary test_write.tmp file
</commit_message>
<xml_diff>
--- a/Presentations/Statistical_Analysis_LAMBDA_Catalog_CECOP_45min_DARK.pptx
+++ b/Presentations/Statistical_Analysis_LAMBDA_Catalog_CECOP_45min_DARK.pptx
@@ -14466,7 +14466,7 @@
                 </a:solidFill>
                 <a:latin typeface="Arial"/>
               </a:rPr>
-              <a:t>One row per column of your source table. Four declarations; the sheet derives the model from them.</a:t>
+              <a:t>One row per column of your source table. Five declarations; the sheet derives the model from them.</a:t>
             </a:r>
           </a:p>
         </p:txBody>
@@ -14477,55 +14477,22 @@
           <p:cNvGraphicFramePr>
             <a:graphicFrameLocks noGrp="1"/>
           </p:cNvGraphicFramePr>
-          <p:nvPr>
-            <p:extLst>
-              <p:ext uri="{D42A27DB-BD31-4B8C-83A1-F6EECF244321}">
-                <p14:modId xmlns:p14="http://schemas.microsoft.com/office/powerpoint/2010/main" val="3638656823"/>
-              </p:ext>
-            </p:extLst>
-          </p:nvPr>
+          <p:nvPr/>
         </p:nvGraphicFramePr>
         <p:xfrm>
-          <a:off x="566928" y="1950000"/>
-          <a:ext cx="11057835" cy="3562000"/>
+          <a:off x="566928" y="1870512"/>
+          <a:ext cx="11057835" cy="2640000"/>
         </p:xfrm>
         <a:graphic>
           <a:graphicData uri="http://schemas.openxmlformats.org/drawingml/2006/table">
             <a:tbl>
-              <a:tblPr firstRow="1" bandRow="1">
-                <a:tableStyleId>{5C22544A-7EE6-4342-B048-85BDC9FD1C3A}</a:tableStyleId>
-              </a:tblPr>
+              <a:tblPr firstRow="1" bandRow="0"/>
               <a:tblGrid>
-                <a:gridCol w="1600000">
-                  <a:extLst>
-                    <a:ext uri="{9D8B030D-6E8A-4147-A177-3AD203B41FA5}">
-                      <a16:colId xmlns:a16="http://schemas.microsoft.com/office/drawing/2014/main" val="20000"/>
-                    </a:ext>
-                  </a:extLst>
-                </a:gridCol>
-                <a:gridCol w="2400000">
-                  <a:extLst>
-                    <a:ext uri="{9D8B030D-6E8A-4147-A177-3AD203B41FA5}">
-                      <a16:colId xmlns:a16="http://schemas.microsoft.com/office/drawing/2014/main" val="20001"/>
-                    </a:ext>
-                  </a:extLst>
-                </a:gridCol>
-                <a:gridCol w="4657835">
-                  <a:extLst>
-                    <a:ext uri="{9D8B030D-6E8A-4147-A177-3AD203B41FA5}">
-                      <a16:colId xmlns:a16="http://schemas.microsoft.com/office/drawing/2014/main" val="20002"/>
-                    </a:ext>
-                  </a:extLst>
-                </a:gridCol>
-                <a:gridCol w="2400000">
-                  <a:extLst>
-                    <a:ext uri="{9D8B030D-6E8A-4147-A177-3AD203B41FA5}">
-                      <a16:colId xmlns:a16="http://schemas.microsoft.com/office/drawing/2014/main" val="20003"/>
-                    </a:ext>
-                  </a:extLst>
-                </a:gridCol>
+                <a:gridCol w="1700000"/>
+                <a:gridCol w="3200000"/>
+                <a:gridCol w="6157835"/>
               </a:tblGrid>
-              <a:tr h="560000">
+              <a:tr h="440000">
                 <a:tc>
                   <a:txBody>
                     <a:bodyPr/>
@@ -14595,36 +14562,8 @@
                     </a:solidFill>
                   </a:tcPr>
                 </a:tc>
-                <a:tc>
-                  <a:txBody>
-                    <a:bodyPr/>
-                    <a:lstStyle/>
-                    <a:p>
-                      <a:pPr algn="ctr"/>
-                      <a:r>
-                        <a:rPr sz="1200" b="1">
-                          <a:solidFill>
-                            <a:srgbClr val="FFFFFF"/>
-                          </a:solidFill>
-                          <a:latin typeface="Arial"/>
-                        </a:rPr>
-                        <a:t>Set by</a:t>
-                      </a:r>
-                    </a:p>
-                  </a:txBody>
-                  <a:tcPr anchor="ctr">
-                    <a:solidFill>
-                      <a:srgbClr val="423781"/>
-                    </a:solidFill>
-                  </a:tcPr>
-                </a:tc>
-                <a:extLst>
-                  <a:ext uri="{0D108BD9-81ED-4DB2-BD59-A6C34878D82A}">
-                    <a16:rowId xmlns:a16="http://schemas.microsoft.com/office/drawing/2014/main" val="10000"/>
-                  </a:ext>
-                </a:extLst>
               </a:tr>
-              <a:tr h="560000">
+              <a:tr h="440000">
                 <a:tc>
                   <a:txBody>
                     <a:bodyPr/>
@@ -14691,36 +14630,8 @@
                     </a:solidFill>
                   </a:tcPr>
                 </a:tc>
-                <a:tc>
-                  <a:txBody>
-                    <a:bodyPr/>
-                    <a:lstStyle/>
-                    <a:p>
-                      <a:pPr algn="ctr"/>
-                      <a:r>
-                        <a:rPr sz="1800" b="1">
-                          <a:solidFill>
-                            <a:srgbClr val="5FD4C6"/>
-                          </a:solidFill>
-                          <a:latin typeface="Arial"/>
-                        </a:rPr>
-                        <a:t>you</a:t>
-                      </a:r>
-                    </a:p>
-                  </a:txBody>
-                  <a:tcPr anchor="ctr">
-                    <a:solidFill>
-                      <a:srgbClr val="454545"/>
-                    </a:solidFill>
-                  </a:tcPr>
-                </a:tc>
-                <a:extLst>
-                  <a:ext uri="{0D108BD9-81ED-4DB2-BD59-A6C34878D82A}">
-                    <a16:rowId xmlns:a16="http://schemas.microsoft.com/office/drawing/2014/main" val="10001"/>
-                  </a:ext>
-                </a:extLst>
               </a:tr>
-              <a:tr h="560000">
+              <a:tr h="440000">
                 <a:tc>
                   <a:txBody>
                     <a:bodyPr/>
@@ -14787,36 +14698,8 @@
                     </a:solidFill>
                   </a:tcPr>
                 </a:tc>
-                <a:tc>
-                  <a:txBody>
-                    <a:bodyPr/>
-                    <a:lstStyle/>
-                    <a:p>
-                      <a:pPr algn="ctr"/>
-                      <a:r>
-                        <a:rPr sz="1800" b="1">
-                          <a:solidFill>
-                            <a:srgbClr val="5FD4C6"/>
-                          </a:solidFill>
-                          <a:latin typeface="Arial"/>
-                        </a:rPr>
-                        <a:t>you</a:t>
-                      </a:r>
-                    </a:p>
-                  </a:txBody>
-                  <a:tcPr anchor="ctr">
-                    <a:solidFill>
-                      <a:srgbClr val="454545"/>
-                    </a:solidFill>
-                  </a:tcPr>
-                </a:tc>
-                <a:extLst>
-                  <a:ext uri="{0D108BD9-81ED-4DB2-BD59-A6C34878D82A}">
-                    <a16:rowId xmlns:a16="http://schemas.microsoft.com/office/drawing/2014/main" val="10002"/>
-                  </a:ext>
-                </a:extLst>
               </a:tr>
-              <a:tr h="560000">
+              <a:tr h="440000">
                 <a:tc>
                   <a:txBody>
                     <a:bodyPr/>
@@ -14883,20 +14766,21 @@
                     </a:solidFill>
                   </a:tcPr>
                 </a:tc>
+              </a:tr>
+              <a:tr h="440000">
                 <a:tc>
                   <a:txBody>
                     <a:bodyPr/>
                     <a:lstStyle/>
                     <a:p>
-                      <a:pPr algn="ctr"/>
                       <a:r>
-                        <a:rPr sz="1800" b="1">
+                        <a:rPr sz="1300" b="1">
                           <a:solidFill>
                             <a:srgbClr val="5FD4C6"/>
                           </a:solidFill>
-                          <a:latin typeface="Arial"/>
+                          <a:latin typeface="Consolas"/>
                         </a:rPr>
-                        <a:t>you</a:t>
+                        <a:t>Transform</a:t>
                       </a:r>
                     </a:p>
                   </a:txBody>
@@ -14906,13 +14790,52 @@
                     </a:solidFill>
                   </a:tcPr>
                 </a:tc>
-                <a:extLst>
-                  <a:ext uri="{0D108BD9-81ED-4DB2-BD59-A6C34878D82A}">
-                    <a16:rowId xmlns:a16="http://schemas.microsoft.com/office/drawing/2014/main" val="10003"/>
-                  </a:ext>
-                </a:extLst>
+                <a:tc>
+                  <a:txBody>
+                    <a:bodyPr/>
+                    <a:lstStyle/>
+                    <a:p>
+                      <a:r>
+                        <a:rPr sz="1200" b="0">
+                          <a:solidFill>
+                            <a:srgbClr val="DCDCDC"/>
+                          </a:solidFill>
+                          <a:latin typeface="Arial"/>
+                        </a:rPr>
+                        <a:t>How the column enters the fit, before anything else</a:t>
+                      </a:r>
+                    </a:p>
+                  </a:txBody>
+                  <a:tcPr anchor="ctr">
+                    <a:solidFill>
+                      <a:srgbClr val="454545"/>
+                    </a:solidFill>
+                  </a:tcPr>
+                </a:tc>
+                <a:tc>
+                  <a:txBody>
+                    <a:bodyPr/>
+                    <a:lstStyle/>
+                    <a:p>
+                      <a:r>
+                        <a:rPr sz="1200" b="0">
+                          <a:solidFill>
+                            <a:srgbClr val="5FD4C6"/>
+                          </a:solidFill>
+                          <a:latin typeface="Consolas"/>
+                        </a:rPr>
+                        <a:t>None · Log</a:t>
+                      </a:r>
+                    </a:p>
+                  </a:txBody>
+                  <a:tcPr anchor="ctr">
+                    <a:solidFill>
+                      <a:srgbClr val="454545"/>
+                    </a:solidFill>
+                  </a:tcPr>
+                </a:tc>
               </a:tr>
-              <a:tr h="560000">
+              <a:tr h="440000">
                 <a:tc>
                   <a:txBody>
                     <a:bodyPr/>
@@ -14921,7 +14844,7 @@
                       <a:r>
                         <a:rPr sz="1300" b="1">
                           <a:solidFill>
-                            <a:srgbClr val="9A9A9A"/>
+                            <a:srgbClr val="5FD4C6"/>
                           </a:solidFill>
                           <a:latin typeface="Consolas"/>
                         </a:rPr>
@@ -14943,7 +14866,7 @@
                       <a:r>
                         <a:rPr sz="1200" b="0">
                           <a:solidFill>
-                            <a:srgbClr val="9A9A9A"/>
+                            <a:srgbClr val="DCDCDC"/>
                           </a:solidFill>
                           <a:latin typeface="Arial"/>
                         </a:rPr>
@@ -14963,42 +14886,13 @@
                     <a:lstStyle/>
                     <a:p>
                       <a:r>
-                        <a:rPr sz="1200" b="0" i="1" dirty="0">
+                        <a:rPr sz="1200" b="0">
                           <a:solidFill>
-                            <a:srgbClr val="9A9A9A"/>
+                            <a:srgbClr val="5FD4C6"/>
                           </a:solidFill>
-                          <a:latin typeface="Arial"/>
+                          <a:latin typeface="Consolas"/>
                         </a:rPr>
                         <a:t>TRUE on at most one column</a:t>
-                      </a:r>
-                      <a:endParaRPr sz="1200" b="0" i="1" dirty="0">
-                        <a:solidFill>
-                          <a:srgbClr val="9AA8B5"/>
-                        </a:solidFill>
-                        <a:latin typeface="Arial"/>
-                      </a:endParaRPr>
-                    </a:p>
-                  </a:txBody>
-                  <a:tcPr anchor="ctr">
-                    <a:solidFill>
-                      <a:srgbClr val="454545"/>
-                    </a:solidFill>
-                  </a:tcPr>
-                </a:tc>
-                <a:tc>
-                  <a:txBody>
-                    <a:bodyPr/>
-                    <a:lstStyle/>
-                    <a:p>
-                      <a:pPr algn="ctr"/>
-                      <a:r>
-                        <a:rPr sz="1400" b="0">
-                          <a:solidFill>
-                            <a:srgbClr val="9A9A9A"/>
-                          </a:solidFill>
-                          <a:latin typeface="Arial"/>
-                        </a:rPr>
-                        <a:t>you</a:t>
                       </a:r>
                     </a:p>
                   </a:txBody>
@@ -15008,107 +14902,6 @@
                     </a:solidFill>
                   </a:tcPr>
                 </a:tc>
-                <a:extLst>
-                  <a:ext uri="{0D108BD9-81ED-4DB2-BD59-A6C34878D82A}">
-                    <a16:rowId xmlns:a16="http://schemas.microsoft.com/office/drawing/2014/main" val="10004"/>
-                  </a:ext>
-                </a:extLst>
-              </a:tr>
-              <a:tr h="560000">
-                <a:tc>
-                  <a:txBody>
-                    <a:bodyPr/>
-                    <a:lstStyle/>
-                    <a:p>
-                      <a:r>
-                        <a:rPr sz="1100" b="1">
-                          <a:solidFill>
-                            <a:srgbClr val="9A9A9A"/>
-                          </a:solidFill>
-                          <a:latin typeface="Consolas"/>
-                        </a:rPr>
-                        <a:t>X_s()  ·  Response_Column()  ·  Sample_Include()</a:t>
-                      </a:r>
-                    </a:p>
-                  </a:txBody>
-                  <a:tcPr anchor="ctr">
-                    <a:solidFill>
-                      <a:srgbClr val="454545"/>
-                    </a:solidFill>
-                  </a:tcPr>
-                </a:tc>
-                <a:tc>
-                  <a:txBody>
-                    <a:bodyPr/>
-                    <a:lstStyle/>
-                    <a:p>
-                      <a:r>
-                        <a:rPr sz="1200" b="0">
-                          <a:solidFill>
-                            <a:srgbClr val="9A9A9A"/>
-                          </a:solidFill>
-                          <a:latin typeface="Arial"/>
-                        </a:rPr>
-                        <a:t>The design matrix, the response, and the row mask</a:t>
-                      </a:r>
-                    </a:p>
-                  </a:txBody>
-                  <a:tcPr anchor="ctr">
-                    <a:solidFill>
-                      <a:srgbClr val="454545"/>
-                    </a:solidFill>
-                  </a:tcPr>
-                </a:tc>
-                <a:tc>
-                  <a:txBody>
-                    <a:bodyPr/>
-                    <a:lstStyle/>
-                    <a:p>
-                      <a:r>
-                        <a:rPr sz="1200" b="0" i="1">
-                          <a:solidFill>
-                            <a:srgbClr val="9A9A9A"/>
-                          </a:solidFill>
-                          <a:latin typeface="Arial"/>
-                        </a:rPr>
-                        <a:t>Built from the spec — no ranges to maintain</a:t>
-                      </a:r>
-                    </a:p>
-                  </a:txBody>
-                  <a:tcPr anchor="ctr">
-                    <a:solidFill>
-                      <a:srgbClr val="454545"/>
-                    </a:solidFill>
-                  </a:tcPr>
-                </a:tc>
-                <a:tc>
-                  <a:txBody>
-                    <a:bodyPr/>
-                    <a:lstStyle/>
-                    <a:p>
-                      <a:pPr algn="ctr"/>
-                      <a:r>
-                        <a:rPr sz="1400" b="0" dirty="0">
-                          <a:solidFill>
-                            <a:srgbClr val="9A9A9A"/>
-                          </a:solidFill>
-                          <a:latin typeface="Arial"/>
-                        </a:rPr>
-                        <a:t>derived</a:t>
-                      </a:r>
-                    </a:p>
-                  </a:txBody>
-                  <a:tcPr anchor="ctr">
-                    <a:solidFill>
-                      <a:srgbClr val="454545"/>
-                    </a:solidFill>
-                  </a:tcPr>
-                </a:tc>
-                <a:extLst>
-                  <a:ext uri="{0D108BD9-81ED-4DB2-BD59-A6C34878D82A}">
-                    <a16:rowId xmlns:a16="http://schemas.microsoft.com/office/drawing/2014/main" val="10005"/>
-                  </a:ext>
-                </a:extLst>
               </a:tr>
             </a:tbl>
           </a:graphicData>
@@ -15116,14 +14909,140 @@
       </p:graphicFrame>
       <p:sp>
         <p:nvSpPr>
+          <p:cNvPr id="50" name="Derived Card"/>
+          <p:cNvSpPr/>
+          <p:nvPr/>
+        </p:nvSpPr>
+        <p:spPr>
+          <a:xfrm>
+            <a:off x="566928" y="4630512"/>
+            <a:ext cx="11057835" cy="820000"/>
+          </a:xfrm>
+          <a:prstGeom prst="roundRect">
+            <a:avLst>
+              <a:gd name="adj" fmla="val 6000"/>
+            </a:avLst>
+          </a:prstGeom>
+          <a:solidFill>
+            <a:srgbClr val="423781"/>
+          </a:solidFill>
+          <a:ln>
+            <a:noFill/>
+          </a:ln>
+          <a:effectLst/>
+        </p:spPr>
+        <p:style>
+          <a:lnRef idx="1">
+            <a:schemeClr val="accent1"/>
+          </a:lnRef>
+          <a:fillRef idx="3">
+            <a:schemeClr val="accent1"/>
+          </a:fillRef>
+          <a:effectRef idx="2">
+            <a:schemeClr val="accent1"/>
+          </a:effectRef>
+          <a:fontRef idx="minor">
+            <a:schemeClr val="lt1"/>
+          </a:fontRef>
+        </p:style>
+        <p:txBody>
+          <a:bodyPr rtlCol="0" anchor="ctr"/>
+          <a:lstStyle/>
+          <a:p>
+            <a:pPr algn="ctr"/>
+            <a:endParaRPr/>
+          </a:p>
+        </p:txBody>
+      </p:sp>
+      <p:sp>
+        <p:nvSpPr>
+          <p:cNvPr id="51" name="Derived Eyebrow"/>
+          <p:cNvSpPr txBox="1"/>
+          <p:nvPr/>
+        </p:nvSpPr>
+        <p:spPr>
+          <a:xfrm>
+            <a:off x="786928" y="4710512"/>
+            <a:ext cx="10617835" cy="170000"/>
+          </a:xfrm>
+          <a:prstGeom prst="rect">
+            <a:avLst/>
+          </a:prstGeom>
+          <a:noFill/>
+        </p:spPr>
+        <p:txBody>
+          <a:bodyPr wrap="square" lIns="0" tIns="0" rIns="0" bIns="0" anchor="t"/>
+          <a:lstStyle/>
+          <a:p>
+            <a:pPr algn="l"/>
+            <a:r>
+              <a:rPr lang="en-US" sz="1100" b="1" i="0" dirty="0" spc="150">
+                <a:solidFill>
+                  <a:srgbClr val="5EEAD4"/>
+                </a:solidFill>
+                <a:latin typeface="Arial"/>
+              </a:rPr>
+              <a:t>DERIVED — NOT PART OF THE SPEC</a:t>
+            </a:r>
+          </a:p>
+        </p:txBody>
+      </p:sp>
+      <p:sp>
+        <p:nvSpPr>
+          <p:cNvPr id="52" name="Derived Detail"/>
+          <p:cNvSpPr txBox="1"/>
+          <p:nvPr/>
+        </p:nvSpPr>
+        <p:spPr>
+          <a:xfrm>
+            <a:off x="786928" y="4920512"/>
+            <a:ext cx="10617835" cy="460000"/>
+          </a:xfrm>
+          <a:prstGeom prst="rect">
+            <a:avLst/>
+          </a:prstGeom>
+          <a:noFill/>
+        </p:spPr>
+        <p:txBody>
+          <a:bodyPr wrap="square" lIns="0" tIns="0" rIns="0" bIns="0" anchor="t"/>
+          <a:lstStyle/>
+          <a:p>
+            <a:pPr algn="l">
+              <a:lnSpc>
+                <a:spcPct val="110000"/>
+              </a:lnSpc>
+            </a:pPr>
+            <a:r>
+              <a:rPr sz="1250" b="1" i="0" dirty="0">
+                <a:solidFill>
+                  <a:srgbClr val="5FD4C6"/>
+                </a:solidFill>
+                <a:latin typeface="Consolas"/>
+              </a:rPr>
+              <a:t>X_s()  ·  Response_Column()  ·  Sample_Include()</a:t>
+            </a:r>
+            <a:r>
+              <a:rPr sz="1250" b="0" i="0" dirty="0">
+                <a:solidFill>
+                  <a:srgbClr val="CBD5E1"/>
+                </a:solidFill>
+                <a:latin typeface="Arial"/>
+              </a:rPr>
+              <a:t>  —  the design matrix, the response, and the row mask. Built from the spec above — no ranges to maintain.</a:t>
+            </a:r>
+          </a:p>
+        </p:txBody>
+      </p:sp>
+      <p:sp>
+        <p:nvSpPr>
           <p:cNvPr id="5" name="TextBox 4"/>
           <p:cNvSpPr txBox="1"/>
           <p:nvPr/>
         </p:nvSpPr>
         <p:spPr>
           <a:xfrm>
-            <a:off x="566928" y="5651488"/>
-            <a:ext cx="11057839" cy="350000"/>
+            <a:off x="566928" y="5550512"/>
+            <a:ext cx="11057839" cy="300000"/>
           </a:xfrm>
           <a:prstGeom prst="rect">
             <a:avLst/>
@@ -15302,7 +15221,7 @@
         </p:nvSpPr>
         <p:spPr>
           <a:xfrm>
-            <a:off x="1975104" y="1417320"/>
+            <a:off x="2327148" y="1417320"/>
             <a:ext cx="1335024" cy="310896"/>
           </a:xfrm>
           <a:prstGeom prst="roundRect">
@@ -15351,7 +15270,7 @@
         </p:nvSpPr>
         <p:spPr>
           <a:xfrm>
-            <a:off x="1975104" y="1417320"/>
+            <a:off x="2327148" y="1417320"/>
             <a:ext cx="1335024" cy="310896"/>
           </a:xfrm>
           <a:prstGeom prst="rect">
@@ -15390,7 +15309,7 @@
         </p:nvSpPr>
         <p:spPr>
           <a:xfrm>
-            <a:off x="3383280" y="1417320"/>
+            <a:off x="4087368" y="1417320"/>
             <a:ext cx="1335024" cy="310896"/>
           </a:xfrm>
           <a:prstGeom prst="roundRect">
@@ -15439,7 +15358,7 @@
         </p:nvSpPr>
         <p:spPr>
           <a:xfrm>
-            <a:off x="3383280" y="1417320"/>
+            <a:off x="4087368" y="1417320"/>
             <a:ext cx="1335024" cy="310896"/>
           </a:xfrm>
           <a:prstGeom prst="rect">
@@ -15478,7 +15397,7 @@
         </p:nvSpPr>
         <p:spPr>
           <a:xfrm>
-            <a:off x="4791456" y="1417320"/>
+            <a:off x="5847588" y="1417320"/>
             <a:ext cx="1335024" cy="310896"/>
           </a:xfrm>
           <a:prstGeom prst="roundRect">
@@ -15527,7 +15446,7 @@
         </p:nvSpPr>
         <p:spPr>
           <a:xfrm>
-            <a:off x="4791456" y="1417320"/>
+            <a:off x="5847588" y="1417320"/>
             <a:ext cx="1335024" cy="310896"/>
           </a:xfrm>
           <a:prstGeom prst="rect">
@@ -15566,7 +15485,7 @@
         </p:nvSpPr>
         <p:spPr>
           <a:xfrm>
-            <a:off x="6199632" y="1417320"/>
+            <a:off x="7607808" y="1417320"/>
             <a:ext cx="1335024" cy="310896"/>
           </a:xfrm>
           <a:prstGeom prst="roundRect">
@@ -15615,7 +15534,7 @@
         </p:nvSpPr>
         <p:spPr>
           <a:xfrm>
-            <a:off x="6199632" y="1417320"/>
+            <a:off x="7607808" y="1417320"/>
             <a:ext cx="1335024" cy="310896"/>
           </a:xfrm>
           <a:prstGeom prst="rect">
@@ -15642,94 +15561,6 @@
                 <a:latin typeface="Arial"/>
               </a:rPr>
               <a:t>Sequence</a:t>
-            </a:r>
-          </a:p>
-        </p:txBody>
-      </p:sp>
-      <p:sp>
-        <p:nvSpPr>
-          <p:cNvPr id="13" name="Rounded Rectangle 12"/>
-          <p:cNvSpPr/>
-          <p:nvPr/>
-        </p:nvSpPr>
-        <p:spPr>
-          <a:xfrm>
-            <a:off x="7607808" y="1417320"/>
-            <a:ext cx="1335024" cy="310896"/>
-          </a:xfrm>
-          <a:prstGeom prst="roundRect">
-            <a:avLst>
-              <a:gd name="adj" fmla="val 30000"/>
-            </a:avLst>
-          </a:prstGeom>
-          <a:solidFill>
-            <a:srgbClr val="454545"/>
-          </a:solidFill>
-          <a:ln w="12700">
-            <a:solidFill>
-              <a:srgbClr val="6E6E6E"/>
-            </a:solidFill>
-          </a:ln>
-          <a:effectLst/>
-        </p:spPr>
-        <p:style>
-          <a:lnRef idx="1">
-            <a:schemeClr val="accent1"/>
-          </a:lnRef>
-          <a:fillRef idx="3">
-            <a:schemeClr val="accent1"/>
-          </a:fillRef>
-          <a:effectRef idx="2">
-            <a:schemeClr val="accent1"/>
-          </a:effectRef>
-          <a:fontRef idx="minor">
-            <a:schemeClr val="lt1"/>
-          </a:fontRef>
-        </p:style>
-        <p:txBody>
-          <a:bodyPr rtlCol="0" anchor="ctr"/>
-          <a:lstStyle/>
-          <a:p>
-            <a:pPr algn="ctr"/>
-            <a:endParaRPr/>
-          </a:p>
-        </p:txBody>
-      </p:sp>
-      <p:sp>
-        <p:nvSpPr>
-          <p:cNvPr id="14" name="TextBox 13"/>
-          <p:cNvSpPr txBox="1"/>
-          <p:nvPr/>
-        </p:nvSpPr>
-        <p:spPr>
-          <a:xfrm>
-            <a:off x="7607808" y="1417320"/>
-            <a:ext cx="1335024" cy="310896"/>
-          </a:xfrm>
-          <a:prstGeom prst="rect">
-            <a:avLst/>
-          </a:prstGeom>
-          <a:noFill/>
-        </p:spPr>
-        <p:txBody>
-          <a:bodyPr wrap="square" lIns="0" tIns="0" rIns="0" bIns="0" anchor="ctr">
-            <a:spAutoFit/>
-          </a:bodyPr>
-          <a:lstStyle/>
-          <a:p>
-            <a:pPr algn="ctr">
-              <a:lnSpc>
-                <a:spcPct val="100000"/>
-              </a:lnSpc>
-            </a:pPr>
-            <a:r>
-              <a:rPr sz="1100" b="0" i="0">
-                <a:solidFill>
-                  <a:srgbClr val="C9CDD2"/>
-                </a:solidFill>
-                <a:latin typeface="Arial"/>
-              </a:rPr>
-              <a:t>Fixed Effects</a:t>
             </a:r>
           </a:p>
         </p:txBody>
@@ -16749,29 +16580,62 @@
       </p:sp>
       <p:sp>
         <p:nvSpPr>
-          <p:cNvPr id="5" name="Shape 5"/>
+          <p:cNvPr id="7" name="TextBox 7"/>
+          <p:cNvSpPr txBox="1"/>
+          <p:nvPr/>
+        </p:nvSpPr>
+        <p:spPr>
+          <a:xfrm>
+            <a:off x="2528316" y="5394960"/>
+            <a:ext cx="3017520" cy="566928"/>
+          </a:xfrm>
+          <a:prstGeom prst="rect">
+            <a:avLst/>
+          </a:prstGeom>
+          <a:noFill/>
+        </p:spPr>
+        <p:txBody>
+          <a:bodyPr wrap="square" lIns="0" tIns="0" rIns="0" bIns="0" anchor="t">
+            <a:spAutoFit/>
+          </a:bodyPr>
+          <a:lstStyle/>
+          <a:p>
+            <a:pPr algn="l">
+              <a:lnSpc>
+                <a:spcPct val="100000"/>
+              </a:lnSpc>
+            </a:pPr>
+            <a:r>
+              <a:rPr sz="1200" b="0" i="0">
+                <a:solidFill>
+                  <a:srgbClr val="C9CDD2"/>
+                </a:solidFill>
+                <a:latin typeface="Arial"/>
+              </a:rPr>
+              <a:t>Level codes forced onto one slope — residuals band into stripes that drift off zero.</a:t>
+            </a:r>
+          </a:p>
+        </p:txBody>
+      </p:sp>
+      <p:sp>
+        <p:nvSpPr>
+          <p:cNvPr id="8" name="Shape 8"/>
           <p:cNvSpPr/>
           <p:nvPr/>
         </p:nvSpPr>
         <p:spPr>
           <a:xfrm>
-            <a:off x="2528316" y="2249424"/>
-            <a:ext cx="3017520" cy="3017520"/>
+            <a:off x="6643116" y="1828800"/>
+            <a:ext cx="3017520" cy="310896"/>
           </a:xfrm>
           <a:prstGeom prst="roundRect">
             <a:avLst>
-              <a:gd name="adj" fmla="val 4000"/>
+              <a:gd name="adj" fmla="val 22000"/>
             </a:avLst>
           </a:prstGeom>
           <a:solidFill>
-            <a:srgbClr val="454545"/>
+            <a:srgbClr val="2FB3A6"/>
           </a:solidFill>
-          <a:ln w="15240">
-            <a:solidFill>
-              <a:srgbClr val="6E6E6E"/>
-            </a:solidFill>
-            <a:prstDash val="dash"/>
-          </a:ln>
           <a:effectLst/>
         </p:spPr>
         <p:style>
@@ -16799,14 +16663,14 @@
       </p:sp>
       <p:sp>
         <p:nvSpPr>
-          <p:cNvPr id="6" name="TextBox 6"/>
+          <p:cNvPr id="9" name="TextBox 9"/>
           <p:cNvSpPr txBox="1"/>
           <p:nvPr/>
         </p:nvSpPr>
         <p:spPr>
           <a:xfrm>
-            <a:off x="2528316" y="3621024"/>
-            <a:ext cx="3017520" cy="274320"/>
+            <a:off x="6643116" y="1828800"/>
+            <a:ext cx="3017520" cy="310896"/>
           </a:xfrm>
           <a:prstGeom prst="rect">
             <a:avLst/>
@@ -16825,26 +16689,26 @@
               </a:lnSpc>
             </a:pPr>
             <a:r>
-              <a:rPr sz="1200" b="0" i="1">
-                <a:solidFill>
-                  <a:srgbClr val="9A9A9A"/>
+              <a:rPr sz="1150" b="1" i="0">
+                <a:solidFill>
+                  <a:srgbClr val="FFFFFF"/>
                 </a:solidFill>
                 <a:latin typeface="Arial"/>
               </a:rPr>
-              <a:t>[ paste chart here ]</a:t>
-            </a:r>
-          </a:p>
-        </p:txBody>
-      </p:sp>
-      <p:sp>
-        <p:nvSpPr>
-          <p:cNvPr id="7" name="TextBox 7"/>
+              <a:t>Type = Categorical</a:t>
+            </a:r>
+          </a:p>
+        </p:txBody>
+      </p:sp>
+      <p:sp>
+        <p:nvSpPr>
+          <p:cNvPr id="12" name="TextBox 12"/>
           <p:cNvSpPr txBox="1"/>
           <p:nvPr/>
         </p:nvSpPr>
         <p:spPr>
           <a:xfrm>
-            <a:off x="2528316" y="5394960"/>
+            <a:off x="6643116" y="5394960"/>
             <a:ext cx="3017520" cy="566928"/>
           </a:xfrm>
           <a:prstGeom prst="rect">
@@ -16870,222 +16734,59 @@
                 </a:solidFill>
                 <a:latin typeface="Arial"/>
               </a:rPr>
-              <a:t>Level codes forced onto one slope — residuals band into stripes that drift off zero.</a:t>
-            </a:r>
-          </a:p>
-        </p:txBody>
-      </p:sp>
-      <p:sp>
-        <p:nvSpPr>
-          <p:cNvPr id="8" name="Shape 8"/>
-          <p:cNvSpPr/>
-          <p:nvPr/>
-        </p:nvSpPr>
-        <p:spPr>
-          <a:xfrm>
-            <a:off x="6643116" y="1828800"/>
-            <a:ext cx="3017520" cy="310896"/>
-          </a:xfrm>
-          <a:prstGeom prst="roundRect">
-            <a:avLst>
-              <a:gd name="adj" fmla="val 22000"/>
-            </a:avLst>
-          </a:prstGeom>
-          <a:solidFill>
-            <a:srgbClr val="2FB3A6"/>
-          </a:solidFill>
-          <a:effectLst/>
-        </p:spPr>
-        <p:style>
-          <a:lnRef idx="1">
-            <a:schemeClr val="accent1"/>
-          </a:lnRef>
-          <a:fillRef idx="3">
-            <a:schemeClr val="accent1"/>
-          </a:fillRef>
-          <a:effectRef idx="2">
-            <a:schemeClr val="accent1"/>
-          </a:effectRef>
-          <a:fontRef idx="minor">
-            <a:schemeClr val="lt1"/>
-          </a:fontRef>
-        </p:style>
-        <p:txBody>
-          <a:bodyPr rtlCol="0" anchor="ctr"/>
-          <a:lstStyle/>
-          <a:p>
-            <a:pPr algn="ctr"/>
-            <a:endParaRPr/>
-          </a:p>
-        </p:txBody>
-      </p:sp>
-      <p:sp>
-        <p:nvSpPr>
-          <p:cNvPr id="9" name="TextBox 9"/>
-          <p:cNvSpPr txBox="1"/>
-          <p:nvPr/>
-        </p:nvSpPr>
-        <p:spPr>
-          <a:xfrm>
-            <a:off x="6643116" y="1828800"/>
-            <a:ext cx="3017520" cy="310896"/>
-          </a:xfrm>
-          <a:prstGeom prst="rect">
-            <a:avLst/>
-          </a:prstGeom>
-          <a:noFill/>
-        </p:spPr>
-        <p:txBody>
-          <a:bodyPr wrap="square" lIns="0" tIns="0" rIns="0" bIns="0" anchor="ctr">
-            <a:spAutoFit/>
-          </a:bodyPr>
-          <a:lstStyle/>
-          <a:p>
-            <a:pPr algn="ctr">
-              <a:lnSpc>
-                <a:spcPct val="100000"/>
-              </a:lnSpc>
-            </a:pPr>
-            <a:r>
-              <a:rPr sz="1150" b="1" i="0">
-                <a:solidFill>
-                  <a:srgbClr val="FFFFFF"/>
-                </a:solidFill>
-                <a:latin typeface="Arial"/>
-              </a:rPr>
-              <a:t>Type = Categorical</a:t>
-            </a:r>
-          </a:p>
-        </p:txBody>
-      </p:sp>
-      <p:sp>
-        <p:nvSpPr>
-          <p:cNvPr id="10" name="Shape 10"/>
-          <p:cNvSpPr/>
-          <p:nvPr/>
-        </p:nvSpPr>
+              <a:t>Each level gets its own intercept. The stripes collapse onto zero; k−1 columns built for you.</a:t>
+            </a:r>
+          </a:p>
+        </p:txBody>
+      </p:sp>
+      <p:pic>
+        <p:nvPicPr>
+          <p:cNvPr id="60" name="Chart Continuous"/>
+          <p:cNvPicPr>
+            <a:picLocks noChangeAspect="1"/>
+          </p:cNvPicPr>
+          <p:nvPr/>
+        </p:nvPicPr>
+        <p:blipFill>
+          <a:blip r:embed="rId3"/>
+          <a:stretch>
+            <a:fillRect/>
+          </a:stretch>
+        </p:blipFill>
+        <p:spPr>
+          <a:xfrm>
+            <a:off x="2528316" y="2249424"/>
+            <a:ext cx="3017520" cy="3017520"/>
+          </a:xfrm>
+          <a:prstGeom prst="rect">
+            <a:avLst/>
+          </a:prstGeom>
+        </p:spPr>
+      </p:pic>
+      <p:pic>
+        <p:nvPicPr>
+          <p:cNvPr id="61" name="Chart Categorical"/>
+          <p:cNvPicPr>
+            <a:picLocks noChangeAspect="1"/>
+          </p:cNvPicPr>
+          <p:nvPr/>
+        </p:nvPicPr>
+        <p:blipFill>
+          <a:blip r:embed="rId4"/>
+          <a:stretch>
+            <a:fillRect/>
+          </a:stretch>
+        </p:blipFill>
         <p:spPr>
           <a:xfrm>
             <a:off x="6643116" y="2249424"/>
             <a:ext cx="3017520" cy="3017520"/>
           </a:xfrm>
-          <a:prstGeom prst="roundRect">
-            <a:avLst>
-              <a:gd name="adj" fmla="val 4000"/>
-            </a:avLst>
-          </a:prstGeom>
-          <a:solidFill>
-            <a:srgbClr val="454545"/>
-          </a:solidFill>
-          <a:ln w="15240">
-            <a:solidFill>
-              <a:srgbClr val="6E6E6E"/>
-            </a:solidFill>
-            <a:prstDash val="dash"/>
-          </a:ln>
-          <a:effectLst/>
-        </p:spPr>
-        <p:style>
-          <a:lnRef idx="1">
-            <a:schemeClr val="accent1"/>
-          </a:lnRef>
-          <a:fillRef idx="3">
-            <a:schemeClr val="accent1"/>
-          </a:fillRef>
-          <a:effectRef idx="2">
-            <a:schemeClr val="accent1"/>
-          </a:effectRef>
-          <a:fontRef idx="minor">
-            <a:schemeClr val="lt1"/>
-          </a:fontRef>
-        </p:style>
-        <p:txBody>
-          <a:bodyPr rtlCol="0" anchor="ctr"/>
-          <a:lstStyle/>
-          <a:p>
-            <a:pPr algn="ctr"/>
-            <a:endParaRPr/>
-          </a:p>
-        </p:txBody>
-      </p:sp>
-      <p:sp>
-        <p:nvSpPr>
-          <p:cNvPr id="11" name="TextBox 11"/>
-          <p:cNvSpPr txBox="1"/>
-          <p:nvPr/>
-        </p:nvSpPr>
-        <p:spPr>
-          <a:xfrm>
-            <a:off x="6643116" y="3621024"/>
-            <a:ext cx="3017520" cy="274320"/>
-          </a:xfrm>
-          <a:prstGeom prst="rect">
-            <a:avLst/>
-          </a:prstGeom>
-          <a:noFill/>
-        </p:spPr>
-        <p:txBody>
-          <a:bodyPr wrap="square" lIns="0" tIns="0" rIns="0" bIns="0" anchor="ctr">
-            <a:spAutoFit/>
-          </a:bodyPr>
-          <a:lstStyle/>
-          <a:p>
-            <a:pPr algn="ctr">
-              <a:lnSpc>
-                <a:spcPct val="100000"/>
-              </a:lnSpc>
-            </a:pPr>
-            <a:r>
-              <a:rPr sz="1200" b="0" i="1">
-                <a:solidFill>
-                  <a:srgbClr val="9A9A9A"/>
-                </a:solidFill>
-                <a:latin typeface="Arial"/>
-              </a:rPr>
-              <a:t>[ paste chart here ]</a:t>
-            </a:r>
-          </a:p>
-        </p:txBody>
-      </p:sp>
-      <p:sp>
-        <p:nvSpPr>
-          <p:cNvPr id="12" name="TextBox 12"/>
-          <p:cNvSpPr txBox="1"/>
-          <p:nvPr/>
-        </p:nvSpPr>
-        <p:spPr>
-          <a:xfrm>
-            <a:off x="6643116" y="5394960"/>
-            <a:ext cx="3017520" cy="566928"/>
-          </a:xfrm>
-          <a:prstGeom prst="rect">
-            <a:avLst/>
-          </a:prstGeom>
-          <a:noFill/>
-        </p:spPr>
-        <p:txBody>
-          <a:bodyPr wrap="square" lIns="0" tIns="0" rIns="0" bIns="0" anchor="t">
-            <a:spAutoFit/>
-          </a:bodyPr>
-          <a:lstStyle/>
-          <a:p>
-            <a:pPr algn="l">
-              <a:lnSpc>
-                <a:spcPct val="100000"/>
-              </a:lnSpc>
-            </a:pPr>
-            <a:r>
-              <a:rPr sz="1200" b="0" i="0">
-                <a:solidFill>
-                  <a:srgbClr val="C9CDD2"/>
-                </a:solidFill>
-                <a:latin typeface="Arial"/>
-              </a:rPr>
-              <a:t>Each level gets its own intercept. The stripes collapse onto zero; k−1 columns built for you.</a:t>
-            </a:r>
-          </a:p>
-        </p:txBody>
-      </p:sp>
+          <a:prstGeom prst="rect">
+            <a:avLst/>
+          </a:prstGeom>
+        </p:spPr>
+      </p:pic>
     </p:spTree>
   </p:cSld>
   <p:clrMapOvr>
@@ -22766,14 +22467,14 @@
       </p:sp>
       <p:sp>
         <p:nvSpPr>
-          <p:cNvPr id="3" name="TextBox 2"/>
+          <p:cNvPr id="20" name="Eyebrow Traceability"/>
           <p:cNvSpPr txBox="1"/>
           <p:nvPr/>
         </p:nvSpPr>
         <p:spPr>
           <a:xfrm>
-            <a:off x="566928" y="1481328"/>
-            <a:ext cx="8229600" cy="461665"/>
+            <a:off x="566928" y="1550000"/>
+            <a:ext cx="5300640" cy="200000"/>
           </a:xfrm>
           <a:prstGeom prst="rect">
             <a:avLst/>
@@ -22781,9 +22482,7 @@
           <a:noFill/>
         </p:spPr>
         <p:txBody>
-          <a:bodyPr wrap="square" lIns="0" tIns="0" rIns="0" bIns="0" anchor="t">
-            <a:spAutoFit/>
-          </a:bodyPr>
+          <a:bodyPr wrap="square" lIns="0" tIns="0" rIns="0" bIns="0" anchor="t"/>
           <a:lstStyle/>
           <a:p>
             <a:pPr algn="l">
@@ -22792,33 +22491,64 @@
               </a:lnSpc>
             </a:pPr>
             <a:r>
-              <a:rPr lang="en-US" sz="3000" b="1" i="0" dirty="0">
+              <a:rPr lang="en-US" sz="1200" b="1" i="0" dirty="0" spc="150">
+                <a:solidFill>
+                  <a:srgbClr val="5EEAD4"/>
+                </a:solidFill>
+                <a:latin typeface="Arial"/>
+              </a:rPr>
+              <a:t>TRACEABILITY</a:t>
+            </a:r>
+          </a:p>
+        </p:txBody>
+      </p:sp>
+      <p:sp>
+        <p:nvSpPr>
+          <p:cNvPr id="21" name="Headline Traceability"/>
+          <p:cNvSpPr txBox="1"/>
+          <p:nvPr/>
+        </p:nvSpPr>
+        <p:spPr>
+          <a:xfrm>
+            <a:off x="566928" y="1810000"/>
+            <a:ext cx="5300640" cy="1000000"/>
+          </a:xfrm>
+          <a:prstGeom prst="rect">
+            <a:avLst/>
+          </a:prstGeom>
+          <a:noFill/>
+        </p:spPr>
+        <p:txBody>
+          <a:bodyPr wrap="square" lIns="0" tIns="0" rIns="0" bIns="0" anchor="t"/>
+          <a:lstStyle/>
+          <a:p>
+            <a:pPr algn="l">
+              <a:lnSpc>
+                <a:spcPct val="105000"/>
+              </a:lnSpc>
+            </a:pPr>
+            <a:r>
+              <a:rPr sz="3200" b="1" i="0" dirty="0">
                 <a:solidFill>
                   <a:srgbClr val="FFFFFF"/>
                 </a:solidFill>
                 <a:latin typeface="Arial"/>
               </a:rPr>
-              <a:t>Static Output is the bane of the estimator</a:t>
-            </a:r>
-            <a:endParaRPr sz="3000" b="1" i="0" dirty="0">
-              <a:solidFill>
-                <a:srgbClr val="14233A"/>
-              </a:solidFill>
-              <a:latin typeface="Arial"/>
-            </a:endParaRPr>
-          </a:p>
-        </p:txBody>
-      </p:sp>
-      <p:sp>
-        <p:nvSpPr>
-          <p:cNvPr id="4" name="TextBox 3"/>
+              <a:t>Static output is the bane of the estimator</a:t>
+            </a:r>
+          </a:p>
+        </p:txBody>
+      </p:sp>
+      <p:sp>
+        <p:nvSpPr>
+          <p:cNvPr id="22" name="Subline Traceability"/>
           <p:cNvSpPr txBox="1"/>
           <p:nvPr/>
         </p:nvSpPr>
         <p:spPr>
           <a:xfrm>
-            <a:off x="566928" y="2395728"/>
-            <a:ext cx="6766560" cy="230832"/>
+            <a:off x="566928" y="2910000"/>
+            <a:ext cx="5300640" cy="520000"/>
           </a:xfrm>
           <a:prstGeom prst="rect">
             <a:avLst/>
@@ -22826,44 +22556,313 @@
           <a:noFill/>
         </p:spPr>
         <p:txBody>
-          <a:bodyPr wrap="square" lIns="0" tIns="0" rIns="0" bIns="0" anchor="t">
-            <a:spAutoFit/>
-          </a:bodyPr>
+          <a:bodyPr wrap="square" lIns="0" tIns="0" rIns="0" bIns="0" anchor="t"/>
           <a:lstStyle/>
           <a:p>
             <a:pPr algn="l">
               <a:lnSpc>
+                <a:spcPct val="105000"/>
+              </a:lnSpc>
+            </a:pPr>
+            <a:r>
+              <a:rPr sz="1600" b="0" i="1" dirty="0">
+                <a:solidFill>
+                  <a:srgbClr val="5FD4C6"/>
+                </a:solidFill>
+                <a:latin typeface="Arial"/>
+              </a:rPr>
+              <a:t>When a formula becomes a value, the trail back to the data ends.</a:t>
+            </a:r>
+          </a:p>
+        </p:txBody>
+      </p:sp>
+      <p:sp>
+        <p:nvSpPr>
+          <p:cNvPr id="23" name="fx badge"/>
+          <p:cNvSpPr txBox="1"/>
+          <p:nvPr/>
+        </p:nvSpPr>
+        <p:spPr>
+          <a:xfrm>
+            <a:off x="566928" y="3520000"/>
+            <a:ext cx="300000" cy="230000"/>
+          </a:xfrm>
+          <a:prstGeom prst="rect">
+            <a:avLst/>
+          </a:prstGeom>
+          <a:noFill/>
+        </p:spPr>
+        <p:txBody>
+          <a:bodyPr wrap="square" lIns="0" tIns="0" rIns="0" bIns="0" anchor="t"/>
+          <a:lstStyle/>
+          <a:p>
+            <a:pPr algn="l">
+              <a:lnSpc>
                 <a:spcPct val="100000"/>
               </a:lnSpc>
             </a:pPr>
             <a:r>
-              <a:rPr lang="en-US" sz="1500" b="0" i="1" dirty="0">
+              <a:rPr sz="1200" b="0" i="1" dirty="0">
                 <a:solidFill>
                   <a:srgbClr val="5FD4C6"/>
                 </a:solidFill>
+                <a:latin typeface="Consolas"/>
+              </a:rPr>
+              <a:t>fx</a:t>
+            </a:r>
+          </a:p>
+        </p:txBody>
+      </p:sp>
+      <p:sp>
+        <p:nvSpPr>
+          <p:cNvPr id="24" name="formula text"/>
+          <p:cNvSpPr txBox="1"/>
+          <p:nvPr/>
+        </p:nvSpPr>
+        <p:spPr>
+          <a:xfrm>
+            <a:off x="886928" y="3520000"/>
+            <a:ext cx="4200000" cy="230000"/>
+          </a:xfrm>
+          <a:prstGeom prst="rect">
+            <a:avLst/>
+          </a:prstGeom>
+          <a:noFill/>
+        </p:spPr>
+        <p:txBody>
+          <a:bodyPr wrap="square" lIns="0" tIns="0" rIns="0" bIns="0" anchor="t"/>
+          <a:lstStyle/>
+          <a:p>
+            <a:pPr algn="l">
+              <a:lnSpc>
+                <a:spcPct val="100000"/>
+              </a:lnSpc>
+            </a:pPr>
+            <a:r>
+              <a:rPr sz="1150" b="0" i="0" dirty="0">
+                <a:solidFill>
+                  <a:srgbClr val="DCDCDC"/>
+                </a:solidFill>
+                <a:latin typeface="Consolas"/>
+              </a:rPr>
+              <a:t>=AVERAGE(</a:t>
+            </a:r>
+            <a:r>
+              <a:rPr sz="1150" b="1" i="0" dirty="0">
+                <a:solidFill>
+                  <a:srgbClr val="5FD4C6"/>
+                </a:solidFill>
+                <a:latin typeface="Consolas"/>
+              </a:rPr>
+              <a:t>Cost_Data</a:t>
+            </a:r>
+            <a:r>
+              <a:rPr sz="1150" b="0" i="0" dirty="0">
+                <a:solidFill>
+                  <a:srgbClr val="DCDCDC"/>
+                </a:solidFill>
+                <a:latin typeface="Consolas"/>
+              </a:rPr>
+              <a:t>)</a:t>
+            </a:r>
+          </a:p>
+        </p:txBody>
+      </p:sp>
+      <p:sp>
+        <p:nvSpPr>
+          <p:cNvPr id="25" name="arrow down"/>
+          <p:cNvSpPr txBox="1"/>
+          <p:nvPr/>
+        </p:nvSpPr>
+        <p:spPr>
+          <a:xfrm>
+            <a:off x="566928" y="3780000"/>
+            <a:ext cx="300000" cy="180000"/>
+          </a:xfrm>
+          <a:prstGeom prst="rect">
+            <a:avLst/>
+          </a:prstGeom>
+          <a:noFill/>
+        </p:spPr>
+        <p:txBody>
+          <a:bodyPr wrap="square" lIns="0" tIns="0" rIns="0" bIns="0" anchor="t"/>
+          <a:lstStyle/>
+          <a:p>
+            <a:pPr algn="l">
+              <a:lnSpc>
+                <a:spcPct val="100000"/>
+              </a:lnSpc>
+            </a:pPr>
+            <a:r>
+              <a:rPr sz="1400" b="0" i="0" dirty="0">
+                <a:solidFill>
+                  <a:srgbClr val="8A8A8A"/>
+                </a:solidFill>
                 <a:latin typeface="Arial"/>
               </a:rPr>
-              <a:t>When a formula becomes a value, the trail back to the data ends.</a:t>
-            </a:r>
-            <a:endParaRPr sz="1500" b="0" i="1" dirty="0">
-              <a:solidFill>
-                <a:srgbClr val="5FD4C6"/>
-              </a:solidFill>
-              <a:latin typeface="Arial"/>
-            </a:endParaRPr>
-          </a:p>
-        </p:txBody>
-      </p:sp>
-      <p:sp>
-        <p:nvSpPr>
-          <p:cNvPr id="5" name="Rectangle 4"/>
+              <a:t>↓</a:t>
+            </a:r>
+          </a:p>
+        </p:txBody>
+      </p:sp>
+      <p:sp>
+        <p:nvSpPr>
+          <p:cNvPr id="26" name="static value"/>
+          <p:cNvSpPr txBox="1"/>
+          <p:nvPr/>
+        </p:nvSpPr>
+        <p:spPr>
+          <a:xfrm>
+            <a:off x="566928" y="3990000"/>
+            <a:ext cx="1600000" cy="220000"/>
+          </a:xfrm>
+          <a:prstGeom prst="rect">
+            <a:avLst/>
+          </a:prstGeom>
+          <a:noFill/>
+        </p:spPr>
+        <p:txBody>
+          <a:bodyPr wrap="square" lIns="0" tIns="0" rIns="0" bIns="0" anchor="t"/>
+          <a:lstStyle/>
+          <a:p>
+            <a:pPr algn="l">
+              <a:lnSpc>
+                <a:spcPct val="100000"/>
+              </a:lnSpc>
+            </a:pPr>
+            <a:r>
+              <a:rPr sz="1400" b="1" i="0" dirty="0">
+                <a:solidFill>
+                  <a:srgbClr val="FFFFFF"/>
+                </a:solidFill>
+                <a:latin typeface="Consolas"/>
+              </a:rPr>
+              <a:t>1,247,003</a:t>
+            </a:r>
+          </a:p>
+        </p:txBody>
+      </p:sp>
+      <p:sp>
+        <p:nvSpPr>
+          <p:cNvPr id="27" name="value annotation"/>
+          <p:cNvSpPr txBox="1"/>
+          <p:nvPr/>
+        </p:nvSpPr>
+        <p:spPr>
+          <a:xfrm>
+            <a:off x="2166928" y="3990000"/>
+            <a:ext cx="3700000" cy="220000"/>
+          </a:xfrm>
+          <a:prstGeom prst="rect">
+            <a:avLst/>
+          </a:prstGeom>
+          <a:noFill/>
+        </p:spPr>
+        <p:txBody>
+          <a:bodyPr wrap="square" lIns="0" tIns="0" rIns="0" bIns="0" anchor="t"/>
+          <a:lstStyle/>
+          <a:p>
+            <a:pPr algn="l">
+              <a:lnSpc>
+                <a:spcPct val="100000"/>
+              </a:lnSpc>
+            </a:pPr>
+            <a:r>
+              <a:rPr sz="1150" b="0" i="1" dirty="0">
+                <a:solidFill>
+                  <a:srgbClr val="8A8A8A"/>
+                </a:solidFill>
+                <a:latin typeface="Consolas"/>
+              </a:rPr>
+              <a:t>— the trail back to Cost_Data ends here</a:t>
+            </a:r>
+          </a:p>
+        </p:txBody>
+      </p:sp>
+      <p:sp>
+        <p:nvSpPr>
+          <p:cNvPr id="30" name="Eyebrow Availability"/>
+          <p:cNvSpPr txBox="1"/>
+          <p:nvPr/>
+        </p:nvSpPr>
+        <p:spPr>
+          <a:xfrm>
+            <a:off x="6324432" y="1550000"/>
+            <a:ext cx="5300640" cy="200000"/>
+          </a:xfrm>
+          <a:prstGeom prst="rect">
+            <a:avLst/>
+          </a:prstGeom>
+          <a:noFill/>
+        </p:spPr>
+        <p:txBody>
+          <a:bodyPr wrap="square" lIns="0" tIns="0" rIns="0" bIns="0" anchor="t"/>
+          <a:lstStyle/>
+          <a:p>
+            <a:pPr algn="l">
+              <a:lnSpc>
+                <a:spcPct val="100000"/>
+              </a:lnSpc>
+            </a:pPr>
+            <a:r>
+              <a:rPr lang="en-US" sz="1200" b="1" i="0" dirty="0" spc="150">
+                <a:solidFill>
+                  <a:srgbClr val="5EEAD4"/>
+                </a:solidFill>
+                <a:latin typeface="Arial"/>
+              </a:rPr>
+              <a:t>AVAILABILITY</a:t>
+            </a:r>
+          </a:p>
+        </p:txBody>
+      </p:sp>
+      <p:sp>
+        <p:nvSpPr>
+          <p:cNvPr id="31" name="Headline Availability"/>
+          <p:cNvSpPr txBox="1"/>
+          <p:nvPr/>
+        </p:nvSpPr>
+        <p:spPr>
+          <a:xfrm>
+            <a:off x="6324432" y="1810000"/>
+            <a:ext cx="5300640" cy="550000"/>
+          </a:xfrm>
+          <a:prstGeom prst="rect">
+            <a:avLst/>
+          </a:prstGeom>
+          <a:noFill/>
+        </p:spPr>
+        <p:txBody>
+          <a:bodyPr wrap="square" lIns="0" tIns="0" rIns="0" bIns="0" anchor="t"/>
+          <a:lstStyle/>
+          <a:p>
+            <a:pPr algn="l">
+              <a:lnSpc>
+                <a:spcPct val="105000"/>
+              </a:lnSpc>
+            </a:pPr>
+            <a:r>
+              <a:rPr sz="2200" b="1" i="0" dirty="0">
+                <a:solidFill>
+                  <a:srgbClr val="FFFFFF"/>
+                </a:solidFill>
+                <a:latin typeface="Arial"/>
+              </a:rPr>
+              <a:t>The tools you rely on don't last</a:t>
+            </a:r>
+          </a:p>
+        </p:txBody>
+      </p:sp>
+      <p:sp>
+        <p:nvSpPr>
+          <p:cNvPr id="40" name="Bar License lapses"/>
           <p:cNvSpPr/>
           <p:nvPr/>
         </p:nvSpPr>
         <p:spPr>
           <a:xfrm>
-            <a:off x="566928" y="3108960"/>
-            <a:ext cx="109728" cy="566928"/>
+            <a:off x="6324432" y="2460000"/>
+            <a:ext cx="80000" cy="400000"/>
           </a:xfrm>
           <a:prstGeom prst="rect">
             <a:avLst/>
@@ -22901,14 +22900,14 @@
       </p:sp>
       <p:sp>
         <p:nvSpPr>
-          <p:cNvPr id="6" name="TextBox 5"/>
+          <p:cNvPr id="41" name="Row License lapses"/>
           <p:cNvSpPr txBox="1"/>
           <p:nvPr/>
         </p:nvSpPr>
         <p:spPr>
           <a:xfrm>
-            <a:off x="841247" y="3063240"/>
-            <a:ext cx="2926080" cy="640080"/>
+            <a:off x="6544432" y="2450000"/>
+            <a:ext cx="5080640" cy="460000"/>
           </a:xfrm>
           <a:prstGeom prst="rect">
             <a:avLst/>
@@ -22916,15 +22915,16 @@
           <a:noFill/>
         </p:spPr>
         <p:txBody>
-          <a:bodyPr wrap="square" lIns="0" tIns="0" rIns="0" bIns="0" anchor="ctr">
-            <a:spAutoFit/>
-          </a:bodyPr>
+          <a:bodyPr wrap="square" lIns="0" tIns="0" rIns="0" bIns="0" anchor="t"/>
           <a:lstStyle/>
           <a:p>
             <a:pPr algn="l">
               <a:lnSpc>
                 <a:spcPct val="100000"/>
               </a:lnSpc>
+              <a:spcAft>
+                <a:spcPts val="200"/>
+              </a:spcAft>
             </a:pPr>
             <a:r>
               <a:rPr sz="1600" b="1" i="0" dirty="0">
@@ -22936,29 +22936,6 @@
               <a:t>License lapses</a:t>
             </a:r>
           </a:p>
-        </p:txBody>
-      </p:sp>
-      <p:sp>
-        <p:nvSpPr>
-          <p:cNvPr id="7" name="TextBox 6"/>
-          <p:cNvSpPr txBox="1"/>
-          <p:nvPr/>
-        </p:nvSpPr>
-        <p:spPr>
-          <a:xfrm>
-            <a:off x="3767328" y="3063240"/>
-            <a:ext cx="3383280" cy="640080"/>
-          </a:xfrm>
-          <a:prstGeom prst="rect">
-            <a:avLst/>
-          </a:prstGeom>
-          <a:noFill/>
-        </p:spPr>
-        <p:txBody>
-          <a:bodyPr wrap="square" lIns="0" tIns="0" rIns="0" bIns="0" anchor="ctr">
-            <a:spAutoFit/>
-          </a:bodyPr>
-          <a:lstStyle/>
           <a:p>
             <a:pPr algn="l">
               <a:lnSpc>
@@ -22966,7 +22943,7 @@
               </a:lnSpc>
             </a:pPr>
             <a:r>
-              <a:rPr sz="1350" b="0" i="0">
+              <a:rPr sz="1350" b="0" i="0" dirty="0">
                 <a:solidFill>
                   <a:srgbClr val="C9CDD2"/>
                 </a:solidFill>
@@ -22979,14 +22956,14 @@
       </p:sp>
       <p:sp>
         <p:nvSpPr>
-          <p:cNvPr id="8" name="Rectangle 7"/>
+          <p:cNvPr id="42" name="Bar Version sunsets"/>
           <p:cNvSpPr/>
           <p:nvPr/>
         </p:nvSpPr>
         <p:spPr>
           <a:xfrm>
-            <a:off x="566928" y="3858768"/>
-            <a:ext cx="109728" cy="566928"/>
+            <a:off x="6324432" y="3060000"/>
+            <a:ext cx="80000" cy="400000"/>
           </a:xfrm>
           <a:prstGeom prst="rect">
             <a:avLst/>
@@ -23024,14 +23001,14 @@
       </p:sp>
       <p:sp>
         <p:nvSpPr>
-          <p:cNvPr id="9" name="TextBox 8"/>
+          <p:cNvPr id="43" name="Row Version sunsets"/>
           <p:cNvSpPr txBox="1"/>
           <p:nvPr/>
         </p:nvSpPr>
         <p:spPr>
           <a:xfrm>
-            <a:off x="841247" y="3813048"/>
-            <a:ext cx="2926080" cy="640080"/>
+            <a:off x="6544432" y="3050000"/>
+            <a:ext cx="5080640" cy="460000"/>
           </a:xfrm>
           <a:prstGeom prst="rect">
             <a:avLst/>
@@ -23039,18 +23016,19 @@
           <a:noFill/>
         </p:spPr>
         <p:txBody>
-          <a:bodyPr wrap="square" lIns="0" tIns="0" rIns="0" bIns="0" anchor="ctr">
-            <a:spAutoFit/>
-          </a:bodyPr>
+          <a:bodyPr wrap="square" lIns="0" tIns="0" rIns="0" bIns="0" anchor="t"/>
           <a:lstStyle/>
           <a:p>
             <a:pPr algn="l">
               <a:lnSpc>
                 <a:spcPct val="100000"/>
               </a:lnSpc>
-            </a:pPr>
-            <a:r>
-              <a:rPr sz="1600" b="1" i="0">
+              <a:spcAft>
+                <a:spcPts val="200"/>
+              </a:spcAft>
+            </a:pPr>
+            <a:r>
+              <a:rPr sz="1600" b="1" i="0" dirty="0">
                 <a:solidFill>
                   <a:srgbClr val="FFFFFF"/>
                 </a:solidFill>
@@ -23059,29 +23037,6 @@
               <a:t>Version sunsets</a:t>
             </a:r>
           </a:p>
-        </p:txBody>
-      </p:sp>
-      <p:sp>
-        <p:nvSpPr>
-          <p:cNvPr id="10" name="TextBox 9"/>
-          <p:cNvSpPr txBox="1"/>
-          <p:nvPr/>
-        </p:nvSpPr>
-        <p:spPr>
-          <a:xfrm>
-            <a:off x="3767328" y="3813048"/>
-            <a:ext cx="3383280" cy="640080"/>
-          </a:xfrm>
-          <a:prstGeom prst="rect">
-            <a:avLst/>
-          </a:prstGeom>
-          <a:noFill/>
-        </p:spPr>
-        <p:txBody>
-          <a:bodyPr wrap="square" lIns="0" tIns="0" rIns="0" bIns="0" anchor="ctr">
-            <a:spAutoFit/>
-          </a:bodyPr>
-          <a:lstStyle/>
           <a:p>
             <a:pPr algn="l">
               <a:lnSpc>
@@ -23089,7 +23044,7 @@
               </a:lnSpc>
             </a:pPr>
             <a:r>
-              <a:rPr sz="1350" b="0" i="0">
+              <a:rPr sz="1350" b="0" i="0" dirty="0">
                 <a:solidFill>
                   <a:srgbClr val="C9CDD2"/>
                 </a:solidFill>
@@ -23102,14 +23057,14 @@
       </p:sp>
       <p:sp>
         <p:nvSpPr>
-          <p:cNvPr id="11" name="Rectangle 10"/>
+          <p:cNvPr id="44" name="Bar Review tightens"/>
           <p:cNvSpPr/>
           <p:nvPr/>
         </p:nvSpPr>
         <p:spPr>
           <a:xfrm>
-            <a:off x="566928" y="4608576"/>
-            <a:ext cx="109728" cy="566928"/>
+            <a:off x="6324432" y="3660000"/>
+            <a:ext cx="80000" cy="400000"/>
           </a:xfrm>
           <a:prstGeom prst="rect">
             <a:avLst/>
@@ -23147,14 +23102,14 @@
       </p:sp>
       <p:sp>
         <p:nvSpPr>
-          <p:cNvPr id="12" name="TextBox 11"/>
+          <p:cNvPr id="45" name="Row Review tightens"/>
           <p:cNvSpPr txBox="1"/>
           <p:nvPr/>
         </p:nvSpPr>
         <p:spPr>
           <a:xfrm>
-            <a:off x="841247" y="4562856"/>
-            <a:ext cx="2926080" cy="640080"/>
+            <a:off x="6544432" y="3650000"/>
+            <a:ext cx="5080640" cy="460000"/>
           </a:xfrm>
           <a:prstGeom prst="rect">
             <a:avLst/>
@@ -23162,18 +23117,19 @@
           <a:noFill/>
         </p:spPr>
         <p:txBody>
-          <a:bodyPr wrap="square" lIns="0" tIns="0" rIns="0" bIns="0" anchor="ctr">
-            <a:spAutoFit/>
-          </a:bodyPr>
+          <a:bodyPr wrap="square" lIns="0" tIns="0" rIns="0" bIns="0" anchor="t"/>
           <a:lstStyle/>
           <a:p>
             <a:pPr algn="l">
               <a:lnSpc>
                 <a:spcPct val="100000"/>
               </a:lnSpc>
-            </a:pPr>
-            <a:r>
-              <a:rPr sz="1600" b="1" i="0">
+              <a:spcAft>
+                <a:spcPts val="200"/>
+              </a:spcAft>
+            </a:pPr>
+            <a:r>
+              <a:rPr sz="1600" b="1" i="0" dirty="0">
                 <a:solidFill>
                   <a:srgbClr val="FFFFFF"/>
                 </a:solidFill>
@@ -23182,29 +23138,6 @@
               <a:t>Review tightens</a:t>
             </a:r>
           </a:p>
-        </p:txBody>
-      </p:sp>
-      <p:sp>
-        <p:nvSpPr>
-          <p:cNvPr id="13" name="TextBox 12"/>
-          <p:cNvSpPr txBox="1"/>
-          <p:nvPr/>
-        </p:nvSpPr>
-        <p:spPr>
-          <a:xfrm>
-            <a:off x="3767328" y="4562856"/>
-            <a:ext cx="3383280" cy="640080"/>
-          </a:xfrm>
-          <a:prstGeom prst="rect">
-            <a:avLst/>
-          </a:prstGeom>
-          <a:noFill/>
-        </p:spPr>
-        <p:txBody>
-          <a:bodyPr wrap="square" lIns="0" tIns="0" rIns="0" bIns="0" anchor="ctr">
-            <a:spAutoFit/>
-          </a:bodyPr>
-          <a:lstStyle/>
           <a:p>
             <a:pPr algn="l">
               <a:lnSpc>
@@ -23212,7 +23145,7 @@
               </a:lnSpc>
             </a:pPr>
             <a:r>
-              <a:rPr sz="1350" b="0" i="0">
+              <a:rPr sz="1350" b="0" i="0" dirty="0">
                 <a:solidFill>
                   <a:srgbClr val="C9CDD2"/>
                 </a:solidFill>
@@ -23225,14 +23158,14 @@
       </p:sp>
       <p:sp>
         <p:nvSpPr>
-          <p:cNvPr id="14" name="Rounded Rectangle 13"/>
+          <p:cNvPr id="46" name="Resolution Card"/>
           <p:cNvSpPr/>
           <p:nvPr/>
         </p:nvSpPr>
         <p:spPr>
           <a:xfrm>
-            <a:off x="8183879" y="2971800"/>
-            <a:ext cx="3456432" cy="2514600"/>
+            <a:off x="566928" y="4430000"/>
+            <a:ext cx="11058144" cy="1400000"/>
           </a:xfrm>
           <a:prstGeom prst="roundRect">
             <a:avLst>
@@ -23272,14 +23205,14 @@
       </p:sp>
       <p:sp>
         <p:nvSpPr>
-          <p:cNvPr id="15" name="TextBox 14"/>
+          <p:cNvPr id="47" name="Eyebrow Result"/>
           <p:cNvSpPr txBox="1"/>
           <p:nvPr/>
         </p:nvSpPr>
         <p:spPr>
           <a:xfrm>
-            <a:off x="8458200" y="3200400"/>
-            <a:ext cx="2926080" cy="184666"/>
+            <a:off x="796928" y="4580000"/>
+            <a:ext cx="5300640" cy="200000"/>
           </a:xfrm>
           <a:prstGeom prst="rect">
             <a:avLst/>
@@ -23287,9 +23220,7 @@
           <a:noFill/>
         </p:spPr>
         <p:txBody>
-          <a:bodyPr wrap="square" lIns="0" tIns="0" rIns="0" bIns="0" anchor="t">
-            <a:spAutoFit/>
-          </a:bodyPr>
+          <a:bodyPr wrap="square" lIns="0" tIns="0" rIns="0" bIns="0" anchor="t"/>
           <a:lstStyle/>
           <a:p>
             <a:pPr algn="l">
@@ -23298,42 +23229,110 @@
               </a:lnSpc>
             </a:pPr>
             <a:r>
-              <a:rPr sz="1200" b="1" i="0" dirty="0">
+              <a:rPr lang="en-US" sz="1200" b="1" i="0" dirty="0" spc="150">
                 <a:solidFill>
                   <a:srgbClr val="5EEAD4"/>
                 </a:solidFill>
                 <a:latin typeface="Arial"/>
               </a:rPr>
-              <a:t>THE </a:t>
-            </a:r>
-            <a:r>
-              <a:rPr lang="en-US" sz="1200" b="1" dirty="0">
+              <a:t>THE RESULT</a:t>
+            </a:r>
+          </a:p>
+        </p:txBody>
+      </p:sp>
+      <p:sp>
+        <p:nvSpPr>
+          <p:cNvPr id="48" name="Result Headline"/>
+          <p:cNvSpPr txBox="1"/>
+          <p:nvPr/>
+        </p:nvSpPr>
+        <p:spPr>
+          <a:xfrm>
+            <a:off x="796928" y="4810000"/>
+            <a:ext cx="10598144" cy="380000"/>
+          </a:xfrm>
+          <a:prstGeom prst="rect">
+            <a:avLst/>
+          </a:prstGeom>
+          <a:noFill/>
+        </p:spPr>
+        <p:txBody>
+          <a:bodyPr wrap="square" lIns="0" tIns="0" rIns="0" bIns="0" anchor="t"/>
+          <a:lstStyle/>
+          <a:p>
+            <a:pPr algn="l">
+              <a:lnSpc>
+                <a:spcPct val="100000"/>
+              </a:lnSpc>
+            </a:pPr>
+            <a:r>
+              <a:rPr sz="2200" b="1" i="0" dirty="0">
+                <a:solidFill>
+                  <a:srgbClr val="FFFFFF"/>
+                </a:solidFill>
+                <a:latin typeface="Arial"/>
+              </a:rPr>
+              <a:t>Traceable Analysis in Vanilla Excel</a:t>
+            </a:r>
+          </a:p>
+        </p:txBody>
+      </p:sp>
+      <p:sp>
+        <p:nvSpPr>
+          <p:cNvPr id="49" name="Clause Traceability"/>
+          <p:cNvSpPr txBox="1"/>
+          <p:nvPr/>
+        </p:nvSpPr>
+        <p:spPr>
+          <a:xfrm>
+            <a:off x="796928" y="5250000"/>
+            <a:ext cx="5199072" cy="430000"/>
+          </a:xfrm>
+          <a:prstGeom prst="rect">
+            <a:avLst/>
+          </a:prstGeom>
+          <a:noFill/>
+        </p:spPr>
+        <p:txBody>
+          <a:bodyPr wrap="square" lIns="0" tIns="0" rIns="0" bIns="0" anchor="t"/>
+          <a:lstStyle/>
+          <a:p>
+            <a:pPr algn="l">
+              <a:lnSpc>
+                <a:spcPct val="105000"/>
+              </a:lnSpc>
+            </a:pPr>
+            <a:r>
+              <a:rPr sz="1350" b="1" i="0" dirty="0">
                 <a:solidFill>
                   <a:srgbClr val="5EEAD4"/>
                 </a:solidFill>
                 <a:latin typeface="Arial"/>
               </a:rPr>
-              <a:t>FIX</a:t>
-            </a:r>
-            <a:endParaRPr sz="1200" b="1" i="0" dirty="0">
-              <a:solidFill>
-                <a:srgbClr val="5EEAD4"/>
-              </a:solidFill>
-              <a:latin typeface="Arial"/>
-            </a:endParaRPr>
-          </a:p>
-        </p:txBody>
-      </p:sp>
-      <p:sp>
-        <p:nvSpPr>
-          <p:cNvPr id="16" name="TextBox 15"/>
+              <a:t>Traceability — </a:t>
+            </a:r>
+            <a:r>
+              <a:rPr sz="1350" b="0" i="0" dirty="0">
+                <a:solidFill>
+                  <a:srgbClr val="CBD5E1"/>
+                </a:solidFill>
+                <a:latin typeface="Arial"/>
+              </a:rPr>
+              <a:t>every formula is a visible, clickable trail back to the source.</a:t>
+            </a:r>
+          </a:p>
+        </p:txBody>
+      </p:sp>
+      <p:sp>
+        <p:nvSpPr>
+          <p:cNvPr id="50" name="Clause Availability"/>
           <p:cNvSpPr txBox="1"/>
           <p:nvPr/>
         </p:nvSpPr>
         <p:spPr>
           <a:xfrm>
-            <a:off x="8458200" y="3584448"/>
-            <a:ext cx="2926080" cy="738664"/>
+            <a:off x="6196000" y="5250000"/>
+            <a:ext cx="5199072" cy="430000"/>
           </a:xfrm>
           <a:prstGeom prst="rect">
             <a:avLst/>
@@ -23341,61 +23340,23 @@
           <a:noFill/>
         </p:spPr>
         <p:txBody>
-          <a:bodyPr wrap="square" lIns="0" tIns="0" rIns="0" bIns="0" anchor="t">
-            <a:spAutoFit/>
-          </a:bodyPr>
+          <a:bodyPr wrap="square" lIns="0" tIns="0" rIns="0" bIns="0" anchor="t"/>
           <a:lstStyle/>
           <a:p>
             <a:pPr algn="l">
               <a:lnSpc>
-                <a:spcPct val="100000"/>
-              </a:lnSpc>
-            </a:pPr>
-            <a:r>
-              <a:rPr lang="en-US" sz="2400" b="1" i="0" dirty="0">
-                <a:solidFill>
-                  <a:srgbClr val="FFFFFF"/>
+                <a:spcPct val="105000"/>
+              </a:lnSpc>
+            </a:pPr>
+            <a:r>
+              <a:rPr sz="1350" b="1" i="0" dirty="0">
+                <a:solidFill>
+                  <a:srgbClr val="5EEAD4"/>
                 </a:solidFill>
                 <a:latin typeface="Arial"/>
               </a:rPr>
-              <a:t>Traceable Analysis in Vanilla Excel</a:t>
-            </a:r>
-            <a:endParaRPr sz="2400" b="1" i="0" dirty="0">
-              <a:solidFill>
-                <a:srgbClr val="FFFFFF"/>
-              </a:solidFill>
-              <a:latin typeface="Arial"/>
-            </a:endParaRPr>
-          </a:p>
-        </p:txBody>
-      </p:sp>
-      <p:sp>
-        <p:nvSpPr>
-          <p:cNvPr id="17" name="TextBox 16"/>
-          <p:cNvSpPr txBox="1"/>
-          <p:nvPr/>
-        </p:nvSpPr>
-        <p:spPr>
-          <a:xfrm>
-            <a:off x="8458200" y="4434840"/>
-            <a:ext cx="2971800" cy="914400"/>
-          </a:xfrm>
-          <a:prstGeom prst="rect">
-            <a:avLst/>
-          </a:prstGeom>
-          <a:noFill/>
-        </p:spPr>
-        <p:txBody>
-          <a:bodyPr wrap="square" lIns="0" tIns="0" rIns="0" bIns="0" anchor="t">
-            <a:spAutoFit/>
-          </a:bodyPr>
-          <a:lstStyle/>
-          <a:p>
-            <a:pPr algn="l">
-              <a:lnSpc>
-                <a:spcPct val="105000"/>
-              </a:lnSpc>
-            </a:pPr>
+              <a:t>Availability — </a:t>
+            </a:r>
             <a:r>
               <a:rPr sz="1350" b="0" i="0" dirty="0">
                 <a:solidFill>
@@ -23403,7 +23364,7 @@
                 </a:solidFill>
                 <a:latin typeface="Arial"/>
               </a:rPr>
-              <a:t>Already deployed. Already cleared. Already on every estimator's machine.</a:t>
+              <a:t>already deployed, already cleared, on every estimator’s machine.</a:t>
             </a:r>
           </a:p>
         </p:txBody>
@@ -46171,7 +46132,7 @@
                   <a:srgbClr val="FFFFFF"/>
                 </a:solidFill>
               </a:rPr>
-              <a:t>Two Excel features do the work</a:t>
+              <a:t>Two habits that keep formulas honest</a:t>
             </a:r>
           </a:p>
         </p:txBody>
@@ -46210,7 +46171,7 @@
                 </a:solidFill>
                 <a:latin typeface="Arial"/>
               </a:rPr>
-              <a:t>Technique — worth knowing whether or not you ever open this workbook.</a:t>
+              <a:t>Worth knowing on their own — the real engine is next.</a:t>
             </a:r>
           </a:p>
         </p:txBody>
@@ -54595,4 +54556,21 @@
     <ds:schemaRef ds:uri="http://purl.org/dc/terms/"/>
   </ds:schemaRefs>
 </ds:datastoreItem>
+</file>
+
+<file path=prefix.txt><?xml version="1.0" encoding="UTF-8" standalone="yes"?>
+<p:sld xmlns:a="http://schemas.openxmlformats.org/drawingml/2006/main" xmlns:r="http://schemas.openxmlformats.org/officeDocument/2006/relationships" xmlns:p="http://schemas.openxmlformats.org/presentationml/2006/main"><p:cSld><p:spTree><p:nvGrpSpPr><p:cNvPr id="1" name=""/><p:cNvGrpSpPr/><p:nvPr/></p:nvGrpSpPr><p:grpSpPr><a:xfrm><a:off x="0" y="0"/><a:ext cx="0" cy="0"/><a:chOff x="0" y="0"/><a:chExt cx="0" cy="0"/></a:xfrm></p:grpSpPr><p:sp><p:nvSpPr><p:cNvPr id="2" name="Title 1"/><p:cNvSpPr><a:spLocks noGrp="1"/></p:cNvSpPr><p:nvPr><p:ph type="title"/></p:nvPr></p:nvSpPr><p:spPr/><p:txBody><a:bodyPr/><a:lstStyle/><a:p><a:r><a:rPr lang="en-US" sz="2900" b="1" dirty="0"><a:solidFill><a:srgbClr val="FFFFFF"/></a:solidFill></a:rPr><a:t>Motivation</a:t></a:r><a:endParaRPr sz="2900" b="1" dirty="0"><a:solidFill><a:srgbClr val="FFFFFF"/></a:solidFill></a:endParaRPr></a:p></p:txBody></p:sp>
+</file>
+
+<file path=prefix10.txt><?xml version="1.0" encoding="UTF-8" standalone="yes"?>
+<p:sld xmlns:a="http://schemas.openxmlformats.org/drawingml/2006/main" xmlns:r="http://schemas.openxmlformats.org/officeDocument/2006/relationships" xmlns:p="http://schemas.openxmlformats.org/presentationml/2006/main"><p:cSld><p:spTree><p:nvGrpSpPr><p:cNvPr id="1" name=""/><p:cNvGrpSpPr/><p:nvPr/></p:nvGrpSpPr><p:grpSpPr><a:xfrm><a:off x="0" y="0"/><a:ext cx="0" cy="0"/><a:chOff x="0" y="0"/><a:chExt cx="0" cy="0"/></a:xfrm></p:grpSpPr><p:sp><p:nvSpPr><p:cNvPr id="2" name="Title 1"/><p:cNvSpPr><a:spLocks noGrp="1"/></p:cNvSpPr><p:nvPr><p:ph type="title"/></p:nvPr></p:nvSpPr><p:spPr/><p:txBody><a:bodyPr><a:normAutofit/></a:bodyPr><a:lstStyle/><a:p><a:r><a:rPr sz="2900" dirty="0"><a:solidFill><a:srgbClr val="FFFFFF"/></a:solidFill></a:rPr><a:t>The model spec block</a:t></a:r></a:p></p:txBody></p:sp><p:sp><p:nvSpPr><p:cNvPr id="3" name="TextBox 2"/><p:cNvSpPr txBox="1"/><p:nvPr/></p:nvSpPr><p:spPr><a:xfrm><a:off x="566928" y="1426464"/><a:ext cx="11057839" cy="384048"/></a:xfrm><a:prstGeom prst="rect"><a:avLst/></a:prstGeom><a:noFill/></p:spPr><p:txBody><a:bodyPr wrap="square" lIns="0" tIns="0" rIns="0" bIns="0" anchor="t"><a:spAutoFit/></a:bodyPr><a:lstStyle/><a:p><a:pPr algn="l"><a:lnSpc><a:spcPct val="100000"/></a:lnSpc></a:pPr><a:r><a:rPr sz="1500" b="0" i="1"><a:solidFill><a:srgbClr val="5FD4C6"/></a:solidFill><a:latin typeface="Arial"/></a:rPr><a:t>One row per column of your source table. Four declarations; the sheet derives the model from them.</a:t></a:r></a:p></p:txBody></p:sp>
+</file>
+
+<file path=rest10.txt><p:sp><p:nvSpPr><p:cNvPr id="5" name="TextBox 4"/><p:cNvSpPr txBox="1"/><p:nvPr/></p:nvSpPr><p:spPr><a:xfrm><a:off x="566928" y="5651488"/><a:ext cx="11057839" cy="350000"/></a:xfrm><a:prstGeom prst="rect"><a:avLst/></a:prstGeom><a:noFill/></p:spPr><p:txBody><a:bodyPr wrap="square" lIns="0" tIns="0" rIns="0" bIns="0" anchor="t"><a:spAutoFit/></a:bodyPr><a:lstStyle/><a:p><a:pPr algn="l"><a:lnSpc><a:spcPct val="100000"/></a:lnSpc></a:pPr><a:r><a:rPr sz="1150" b="0" i="1" dirty="0"><a:solidFill><a:srgbClr val="C9CDD2"/></a:solidFill><a:latin typeface="Arial"/></a:rPr><a:t>Nothing is hard-wired. The spec block plus one table reference is the model &#8212; swapping the dependent variable is a dropdown change, not a re-plumbing job.</a:t></a:r></a:p></p:txBody></p:sp></p:spTree></p:cSld><p:clrMapOvr><a:masterClrMapping/></p:clrMapOvr></p:sld>
+</file>
+
+<file path=suffix.txt></p:spTree></p:cSld><p:clrMapOvr><a:masterClrMapping/></p:clrMapOvr></p:sld>
+</file>
+
+<file path=table10.txt><p:graphicFrame><p:nvGraphicFramePr><p:cNvPr id="4" name="Table 3"/><p:cNvGraphicFramePr><a:graphicFrameLocks noGrp="1"/></p:cNvGraphicFramePr><p:nvPr><p:extLst><p:ext uri="{D42A27DB-BD31-4B8C-83A1-F6EECF244321}"><p14:modId xmlns:p14="http://schemas.microsoft.com/office/powerpoint/2010/main" val="3638656823"/></p:ext></p:extLst></p:nvPr></p:nvGraphicFramePr><p:xfrm><a:off x="566928" y="1950000"/><a:ext cx="11057835" cy="3562000"/></p:xfrm><a:graphic><a:graphicData uri="http://schemas.openxmlformats.org/drawingml/2006/table"><a:tbl><a:tblPr firstRow="1" bandRow="1"><a:tableStyleId>{5C22544A-7EE6-4342-B048-85BDC9FD1C3A}</a:tableStyleId></a:tblPr><a:tblGrid><a:gridCol w="1600000"><a:extLst><a:ext uri="{9D8B030D-6E8A-4147-A177-3AD203B41FA5}"><a16:colId xmlns:a16="http://schemas.microsoft.com/office/drawing/2014/main" val="20000"/></a:ext></a:extLst></a:gridCol><a:gridCol w="2400000"><a:extLst><a:ext uri="{9D8B030D-6E8A-4147-A177-3AD203B41FA5}"><a16:colId xmlns:a16="http://schemas.microsoft.com/office/drawing/2014/main" val="20001"/></a:ext></a:extLst></a:gridCol><a:gridCol w="4657835"><a:extLst><a:ext uri="{9D8B030D-6E8A-4147-A177-3AD203B41FA5}"><a16:colId xmlns:a16="http://schemas.microsoft.com/office/drawing/2014/main" val="20002"/></a:ext></a:extLst></a:gridCol><a:gridCol w="2400000"><a:extLst><a:ext uri="{9D8B030D-6E8A-4147-A177-3AD203B41FA5}"><a16:colId xmlns:a16="http://schemas.microsoft.com/office/drawing/2014/main" val="20003"/></a:ext></a:extLst></a:gridCol></a:tblGrid><a:tr h="560000"><a:tc><a:txBody><a:bodyPr/><a:lstStyle/><a:p><a:pPr algn="l"/><a:r><a:rPr sz="1200" b="1"><a:solidFill><a:srgbClr val="FFFFFF"/></a:solidFill><a:latin typeface="Arial"/></a:rPr><a:t>Spec column</a:t></a:r></a:p></a:txBody><a:tcPr anchor="ctr"><a:solidFill><a:srgbClr val="423781"/></a:solidFill></a:tcPr></a:tc><a:tc><a:txBody><a:bodyPr/><a:lstStyle/><a:p><a:pPr algn="l"/><a:r><a:rPr sz="1200" b="1"><a:solidFill><a:srgbClr val="FFFFFF"/></a:solidFill><a:latin typeface="Arial"/></a:rPr><a:t>What it declares</a:t></a:r></a:p></a:txBody><a:tcPr anchor="ctr"><a:solidFill><a:srgbClr val="423781"/></a:solidFill></a:tcPr></a:tc><a:tc><a:txBody><a:bodyPr/><a:lstStyle/><a:p><a:pPr algn="l"/><a:r><a:rPr sz="1200" b="1"><a:solidFill><a:srgbClr val="FFFFFF"/></a:solidFill><a:latin typeface="Arial"/></a:rPr><a:t>Values</a:t></a:r></a:p></a:txBody><a:tcPr anchor="ctr"><a:solidFill><a:srgbClr val="423781"/></a:solidFill></a:tcPr></a:tc><a:tc><a:txBody><a:bodyPr/><a:lstStyle/><a:p><a:pPr algn="ctr"/><a:r><a:rPr sz="1200" b="1"><a:solidFill><a:srgbClr val="FFFFFF"/></a:solidFill><a:latin typeface="Arial"/></a:rPr><a:t>Set by</a:t></a:r></a:p></a:txBody><a:tcPr anchor="ctr"><a:solidFill><a:srgbClr val="423781"/></a:solidFill></a:tcPr></a:tc><a:extLst><a:ext uri="{0D108BD9-81ED-4DB2-BD59-A6C34878D82A}"><a16:rowId xmlns:a16="http://schemas.microsoft.com/office/drawing/2014/main" val="10000"/></a:ext></a:extLst></a:tr><a:tr h="560000"><a:tc><a:txBody><a:bodyPr/><a:lstStyle/><a:p><a:r><a:rPr sz="1300" b="1"><a:solidFill><a:srgbClr val="5FD4C6"/></a:solidFill><a:latin typeface="Consolas"/></a:rPr><a:t>Role</a:t></a:r></a:p></a:txBody><a:tcPr anchor="ctr"><a:solidFill><a:srgbClr val="454545"/></a:solidFill></a:tcPr></a:tc><a:tc><a:txBody><a:bodyPr/><a:lstStyle/><a:p><a:r><a:rPr sz="1200" b="0"><a:solidFill><a:srgbClr val="DCDCDC"/></a:solidFill><a:latin typeface="Arial"/></a:rPr><a:t>What the column is in the model</a:t></a:r></a:p></a:txBody><a:tcPr anchor="ctr"><a:solidFill><a:srgbClr val="454545"/></a:solidFill></a:tcPr></a:tc><a:tc><a:txBody><a:bodyPr/><a:lstStyle/><a:p><a:r><a:rPr sz="1200" b="0"><a:solidFill><a:srgbClr val="5FD4C6"/></a:solidFill><a:latin typeface="Consolas"/></a:rPr><a:t>Response &#183; Predictor &#183; Identifier &#183; Filter &#183; Omit &#183; Fixed Effects</a:t></a:r></a:p></a:txBody><a:tcPr anchor="ctr"><a:solidFill><a:srgbClr val="454545"/></a:solidFill></a:tcPr></a:tc><a:tc><a:txBody><a:bodyPr/><a:lstStyle/><a:p><a:pPr algn="ctr"/><a:r><a:rPr sz="1800" b="1"><a:solidFill><a:srgbClr val="5FD4C6"/></a:solidFill><a:latin typeface="Arial"/></a:rPr><a:t>you</a:t></a:r></a:p></a:txBody><a:tcPr anchor="ctr"><a:solidFill><a:srgbClr val="454545"/></a:solidFill></a:tcPr></a:tc><a:extLst><a:ext uri="{0D108BD9-81ED-4DB2-BD59-A6C34878D82A}"><a16:rowId xmlns:a16="http://schemas.microsoft.com/office/drawing/2014/main" val="10001"/></a:ext></a:extLst></a:tr><a:tr h="560000"><a:tc><a:txBody><a:bodyPr/><a:lstStyle/><a:p><a:r><a:rPr sz="1300" b="1"><a:solidFill><a:srgbClr val="5FD4C6"/></a:solidFill><a:latin typeface="Consolas"/></a:rPr><a:t>Include</a:t></a:r></a:p></a:txBody><a:tcPr anchor="ctr"><a:solidFill><a:srgbClr val="454545"/></a:solidFill></a:tcPr></a:tc><a:tc><a:txBody><a:bodyPr/><a:lstStyle/><a:p><a:r><a:rPr sz="1200" b="0"><a:solidFill><a:srgbClr val="DCDCDC"/></a:solidFill><a:latin typeface="Arial"/></a:rPr><a:t>Whether the column is a candidate in this run</a:t></a:r></a:p></a:txBody><a:tcPr anchor="ctr"><a:solidFill><a:srgbClr val="454545"/></a:solidFill></a:tcPr></a:tc><a:tc><a:txBody><a:bodyPr/><a:lstStyle/><a:p><a:r><a:rPr sz="1200" b="0"><a:solidFill><a:srgbClr val="5FD4C6"/></a:solidFill><a:latin typeface="Consolas"/></a:rPr><a:t>TRUE &#183; FALSE</a:t></a:r></a:p></a:txBody><a:tcPr anchor="ctr"><a:solidFill><a:srgbClr val="454545"/></a:solidFill></a:tcPr></a:tc><a:tc><a:txBody><a:bodyPr/><a:lstStyle/><a:p><a:pPr algn="ctr"/><a:r><a:rPr sz="1800" b="1"><a:solidFill><a:srgbClr val="5FD4C6"/></a:solidFill><a:latin typeface="Arial"/></a:rPr><a:t>you</a:t></a:r></a:p></a:txBody><a:tcPr anchor="ctr"><a:solidFill><a:srgbClr val="454545"/></a:solidFill></a:tcPr></a:tc><a:extLst><a:ext uri="{0D108BD9-81ED-4DB2-BD59-A6C34878D82A}"><a16:rowId xmlns:a16="http://schemas.microsoft.com/office/drawing/2014/main" val="10002"/></a:ext></a:extLst></a:tr><a:tr h="560000"><a:tc><a:txBody><a:bodyPr/><a:lstStyle/><a:p><a:r><a:rPr sz="1300" b="1"><a:solidFill><a:srgbClr val="5FD4C6"/></a:solidFill><a:latin typeface="Consolas"/></a:rPr><a:t>Type</a:t></a:r></a:p></a:txBody><a:tcPr anchor="ctr"><a:solidFill><a:srgbClr val="454545"/></a:solidFill></a:tcPr></a:tc><a:tc><a:txBody><a:bodyPr/><a:lstStyle/><a:p><a:r><a:rPr sz="1200" b="0"><a:solidFill><a:srgbClr val="DCDCDC"/></a:solidFill><a:latin typeface="Arial"/></a:rPr><a:t>How a predictor enters the design matrix</a:t></a:r></a:p></a:txBody><a:tcPr anchor="ctr"><a:solidFill><a:srgbClr val="454545"/></a:solidFill></a:tcPr></a:tc><a:tc><a:txBody><a:bodyPr/><a:lstStyle/><a:p><a:r><a:rPr sz="1200" b="0"><a:solidFill><a:srgbClr val="5FD4C6"/></a:solidFill><a:latin typeface="Consolas"/></a:rPr><a:t>Continuous &#183; Categorical</a:t></a:r></a:p></a:txBody><a:tcPr anchor="ctr"><a:solidFill><a:srgbClr val="454545"/></a:solidFill></a:tcPr></a:tc><a:tc><a:txBody><a:bodyPr/><a:lstStyle/><a:p><a:pPr algn="ctr"/><a:r><a:rPr sz="1800" b="1"><a:solidFill><a:srgbClr val="5FD4C6"/></a:solidFill><a:latin typeface="Arial"/></a:rPr><a:t>you</a:t></a:r></a:p></a:txBody><a:tcPr anchor="ctr"><a:solidFill><a:srgbClr val="454545"/></a:solidFill></a:tcPr></a:tc><a:extLst><a:ext uri="{0D108BD9-81ED-4DB2-BD59-A6C34878D82A}"><a16:rowId xmlns:a16="http://schemas.microsoft.com/office/drawing/2014/main" val="10003"/></a:ext></a:extLst></a:tr><a:tr h="560000"><a:tc><a:txBody><a:bodyPr/><a:lstStyle/><a:p><a:r><a:rPr sz="1300" b="1"><a:solidFill><a:srgbClr val="9A9A9A"/></a:solidFill><a:latin typeface="Consolas"/></a:rPr><a:t>Sequence</a:t></a:r></a:p></a:txBody><a:tcPr anchor="ctr"><a:solidFill><a:srgbClr val="454545"/></a:solidFill></a:tcPr></a:tc><a:tc><a:txBody><a:bodyPr/><a:lstStyle/><a:p><a:r><a:rPr sz="1200" b="0"><a:solidFill><a:srgbClr val="9A9A9A"/></a:solidFill><a:latin typeface="Arial"/></a:rPr><a:t>Which column orders the data</a:t></a:r></a:p></a:txBody><a:tcPr anchor="ctr"><a:solidFill><a:srgbClr val="454545"/></a:solidFill></a:tcPr></a:tc><a:tc><a:txBody><a:bodyPr/><a:lstStyle/><a:p><a:r><a:rPr sz="1200" b="0" i="1" dirty="0"><a:solidFill><a:srgbClr val="9A9A9A"/></a:solidFill><a:latin typeface="Arial"/></a:rPr><a:t>TRUE on at most one column</a:t></a:r><a:endParaRPr sz="1200" b="0" i="1" dirty="0"><a:solidFill><a:srgbClr val="9AA8B5"/></a:solidFill><a:latin typeface="Arial"/></a:endParaRPr></a:p></a:txBody><a:tcPr anchor="ctr"><a:solidFill><a:srgbClr val="454545"/></a:solidFill></a:tcPr></a:tc><a:tc><a:txBody><a:bodyPr/><a:lstStyle/><a:p><a:pPr algn="ctr"/><a:r><a:rPr sz="1400" b="0"><a:solidFill><a:srgbClr val="9A9A9A"/></a:solidFill><a:latin typeface="Arial"/></a:rPr><a:t>you</a:t></a:r></a:p></a:txBody><a:tcPr anchor="ctr"><a:solidFill><a:srgbClr val="454545"/></a:solidFill></a:tcPr></a:tc><a:extLst><a:ext uri="{0D108BD9-81ED-4DB2-BD59-A6C34878D82A}"><a16:rowId xmlns:a16="http://schemas.microsoft.com/office/drawing/2014/main" val="10004"/></a:ext></a:extLst></a:tr><a:tr h="560000"><a:tc><a:txBody><a:bodyPr/><a:lstStyle/><a:p><a:r><a:rPr sz="1100" b="1"><a:solidFill><a:srgbClr val="9A9A9A"/></a:solidFill><a:latin typeface="Consolas"/></a:rPr><a:t>X_s()  &#183;  Response_Column()  &#183;  Sample_Include()</a:t></a:r></a:p></a:txBody><a:tcPr anchor="ctr"><a:solidFill><a:srgbClr val="454545"/></a:solidFill></a:tcPr></a:tc><a:tc><a:txBody><a:bodyPr/><a:lstStyle/><a:p><a:r><a:rPr sz="1200" b="0"><a:solidFill><a:srgbClr val="9A9A9A"/></a:solidFill><a:latin typeface="Arial"/></a:rPr><a:t>The design matrix, the response, and the row mask</a:t></a:r></a:p></a:txBody><a:tcPr anchor="ctr"><a:solidFill><a:srgbClr val="454545"/></a:solidFill></a:tcPr></a:tc><a:tc><a:txBody><a:bodyPr/><a:lstStyle/><a:p><a:r><a:rPr sz="1200" b="0" i="1"><a:solidFill><a:srgbClr val="9A9A9A"/></a:solidFill><a:latin typeface="Arial"/></a:rPr><a:t>Built from the spec &#8212; no ranges to maintain</a:t></a:r></a:p></a:txBody><a:tcPr anchor="ctr"><a:solidFill><a:srgbClr val="454545"/></a:solidFill></a:tcPr></a:tc><a:tc><a:txBody><a:bodyPr/><a:lstStyle/><a:p><a:pPr algn="ctr"/><a:r><a:rPr sz="1400" b="0" dirty="0"><a:solidFill><a:srgbClr val="9A9A9A"/></a:solidFill><a:latin typeface="Arial"/></a:rPr><a:t>derived</a:t></a:r></a:p></a:txBody><a:tcPr anchor="ctr"><a:solidFill><a:srgbClr val="454545"/></a:solidFill></a:tcPr></a:tc><a:extLst><a:ext uri="{0D108BD9-81ED-4DB2-BD59-A6C34878D82A}"><a16:rowId xmlns:a16="http://schemas.microsoft.com/office/drawing/2014/main" val="10005"/></a:ext></a:extLst></a:tr></a:tbl></a:graphicData></a:graphic></p:graphicFrame>
 </file>
</xml_diff>